<commit_message>
feat: Migrate to Agentic Voice, add AI Guardrails and caller identification
</commit_message>
<xml_diff>
--- a/assets/connect-ai-host-arch-diagram.pptx
+++ b/assets/connect-ai-host-arch-diagram.pptx
@@ -230,7 +230,7 @@
           <a:p>
             <a:fld id="{8963D1AE-04B2-F147-8122-2A32BD7879DD}" type="datetimeFigureOut">
               <a:rPr lang="en-US" smtClean="0"/>
-              <a:t>7/30/26</a:t>
+              <a:t>8/4/26</a:t>
             </a:fld>
             <a:endParaRPr lang="en-US" dirty="0"/>
           </a:p>
@@ -2373,7 +2373,7 @@
                 </a:solidFill>
                 <a:latin typeface="Arial"/>
               </a:rPr>
-              <a:t>Amazon Q in Connect AI Agent</a:t>
+              <a:t>Amazon Connect AI Agents</a:t>
             </a:r>
             <a:endParaRPr sz="900" b="1" dirty="0">
               <a:solidFill>
@@ -2845,12 +2845,12 @@
         </p:nvCxnSpPr>
         <p:spPr>
           <a:xfrm rot="5400000">
-            <a:off x="3541391" y="1543621"/>
-            <a:ext cx="875334" cy="3865591"/>
+            <a:off x="3627297" y="1457714"/>
+            <a:ext cx="875334" cy="4037404"/>
           </a:xfrm>
           <a:prstGeom prst="bentConnector3">
             <a:avLst>
-              <a:gd name="adj1" fmla="val 50000"/>
+              <a:gd name="adj1" fmla="val 16710"/>
             </a:avLst>
           </a:prstGeom>
           <a:ln w="15875">
@@ -3641,7 +3641,7 @@
         </p:blipFill>
         <p:spPr>
           <a:xfrm>
-            <a:off x="4926107" y="5367321"/>
+            <a:off x="4892040" y="5367321"/>
             <a:ext cx="365760" cy="365760"/>
           </a:xfrm>
           <a:prstGeom prst="rect">
@@ -3797,7 +3797,7 @@
                 </a:solidFill>
                 <a:latin typeface="Arial"/>
               </a:rPr>
-              <a:t>Amazon Q in Connect</a:t>
+              <a:t>Amazon Connect AI Agents</a:t>
             </a:r>
             <a:r>
               <a:rPr lang="en-US" sz="1000" b="0" dirty="0">
@@ -3864,7 +3864,7 @@
                 </a:solidFill>
                 <a:latin typeface="Arial"/>
               </a:rPr>
-              <a:t> for real-time speech-to-speech interaction.</a:t>
+              <a:t> for speech recognition and synthesis throughout the conversation.</a:t>
             </a:r>
             <a:endParaRPr sz="1000" b="0" dirty="0">
               <a:solidFill>
@@ -3904,7 +3904,7 @@
                 </a:solidFill>
                 <a:latin typeface="Arial"/>
               </a:rPr>
-              <a:t>Amazon Q in Connect </a:t>
+              <a:t>Amazon Connect AI Agents </a:t>
             </a:r>
             <a:r>
               <a:rPr lang="en-US" sz="1000" b="0" dirty="0">
@@ -3953,7 +3953,7 @@
                 </a:solidFill>
                 <a:latin typeface="Arial"/>
               </a:rPr>
-              <a:t>Amazon Q in Connect </a:t>
+              <a:t>Amazon Connect AI Agents </a:t>
             </a:r>
             <a:r>
               <a:rPr lang="en-US" sz="1000" b="0" dirty="0">
@@ -5656,7 +5656,7 @@
           <a:blip>
             <a:extLst>
               <a:ext uri="{96DAC541-7B7A-43D3-8B79-37D633B846F1}">
-                <asvg:svgBlip xmlns:asvg="http://schemas.microsoft.com/office/drawing/2016/SVG/main" r:embed="rId15"/>
+                <asvg:svgBlip xmlns:asvg="http://schemas.microsoft.com/office/drawing/2016/SVG/main" r:embed="rId13"/>
               </a:ext>
             </a:extLst>
           </a:blip>
@@ -5665,7 +5665,7 @@
         </p:blipFill>
         <p:spPr>
           <a:xfrm>
-            <a:off x="5704169" y="2306109"/>
+            <a:off x="5791200" y="2306109"/>
             <a:ext cx="365760" cy="365760"/>
           </a:xfrm>
           <a:prstGeom prst="rect">
@@ -5692,7 +5692,7 @@
         <p:spPr>
           <a:xfrm>
             <a:off x="4284910" y="2480532"/>
-            <a:ext cx="1419259" cy="8457"/>
+            <a:ext cx="1506290" cy="8457"/>
           </a:xfrm>
           <a:prstGeom prst="straightConnector1">
             <a:avLst/>
@@ -5913,8 +5913,8 @@
         </p:nvSpPr>
         <p:spPr bwMode="auto">
           <a:xfrm>
-            <a:off x="5145793" y="2669417"/>
-            <a:ext cx="1532119" cy="369332"/>
+            <a:off x="5233131" y="2669417"/>
+            <a:ext cx="1701069" cy="369332"/>
           </a:xfrm>
           <a:prstGeom prst="rect">
             <a:avLst/>
@@ -6053,7 +6053,7 @@
                 <a:ea typeface="Amazon Ember" panose="020B0603020204020204" pitchFamily="34" charset="0"/>
                 <a:cs typeface="Arial" panose="020B0604020202020204" pitchFamily="34" charset="0"/>
               </a:rPr>
-              <a:t>Amazon Q in Connect</a:t>
+              <a:t>Amazon Connect AI Agents</a:t>
             </a:r>
           </a:p>
           <a:p>
@@ -6087,8 +6087,8 @@
         </p:nvCxnSpPr>
         <p:spPr>
           <a:xfrm>
-            <a:off x="6069929" y="2488989"/>
-            <a:ext cx="1493213" cy="5173"/>
+            <a:off x="6156960" y="2488989"/>
+            <a:ext cx="1406182" cy="5173"/>
           </a:xfrm>
           <a:prstGeom prst="straightConnector1">
             <a:avLst/>
@@ -6134,8 +6134,8 @@
         </p:nvCxnSpPr>
         <p:spPr>
           <a:xfrm rot="5400000" flipH="1" flipV="1">
-            <a:off x="3966655" y="385716"/>
-            <a:ext cx="12700" cy="3840787"/>
+            <a:off x="4010171" y="342200"/>
+            <a:ext cx="12700" cy="3927818"/>
           </a:xfrm>
           <a:prstGeom prst="bentConnector3">
             <a:avLst>

</xml_diff>

<commit_message>
docs: Update architecture diagram for Agentic Voice
</commit_message>
<xml_diff>
--- a/assets/connect-ai-host-arch-diagram.pptx
+++ b/assets/connect-ai-host-arch-diagram.pptx
@@ -230,7 +230,7 @@
           <a:p>
             <a:fld id="{8963D1AE-04B2-F147-8122-2A32BD7879DD}" type="datetimeFigureOut">
               <a:rPr lang="en-US" smtClean="0"/>
-              <a:t>8/4/26</a:t>
+              <a:t>8/5/26</a:t>
             </a:fld>
             <a:endParaRPr lang="en-US" dirty="0"/>
           </a:p>
@@ -2042,13 +2042,22 @@
               <a:t>Amazon </a:t>
             </a:r>
             <a:r>
-              <a:rPr lang="en-US" sz="1200" b="0" dirty="0">
-                <a:solidFill>
-                  <a:srgbClr val="16191F"/>
-                </a:solidFill>
-                <a:latin typeface="Arial"/>
-              </a:rPr>
-              <a:t>Connect Customer</a:t>
+              <a:rPr lang="en-US" sz="1200" b="0">
+                <a:solidFill>
+                  <a:srgbClr val="16191F"/>
+                </a:solidFill>
+                <a:latin typeface="Arial"/>
+              </a:rPr>
+              <a:t>Connect Customer, </a:t>
+            </a:r>
+            <a:r>
+              <a:rPr lang="en-US" sz="1200">
+                <a:solidFill>
+                  <a:srgbClr val="16191F"/>
+                </a:solidFill>
+                <a:latin typeface="Arial"/>
+              </a:rPr>
+              <a:t>Agentic </a:t>
             </a:r>
             <a:r>
               <a:rPr lang="en-US" sz="1200" dirty="0">
@@ -2057,16 +2066,7 @@
                 </a:solidFill>
                 <a:latin typeface="Arial"/>
               </a:rPr>
-              <a:t>, </a:t>
-            </a:r>
-            <a:r>
-              <a:rPr sz="1200" b="0" dirty="0">
-                <a:solidFill>
-                  <a:srgbClr val="16191F"/>
-                </a:solidFill>
-                <a:latin typeface="Arial"/>
-              </a:rPr>
-              <a:t>Nova 2 Sonic</a:t>
+              <a:t>Voice</a:t>
             </a:r>
             <a:r>
               <a:rPr lang="en-US" sz="1200" b="0" dirty="0">
@@ -2804,7 +2804,7 @@
         </p:nvCxnSpPr>
         <p:spPr>
           <a:xfrm flipV="1">
-            <a:off x="625417" y="2488989"/>
+            <a:off x="625417" y="2435941"/>
             <a:ext cx="1237965" cy="5173"/>
           </a:xfrm>
           <a:prstGeom prst="straightConnector1">
@@ -2845,12 +2845,12 @@
         </p:nvCxnSpPr>
         <p:spPr>
           <a:xfrm rot="5400000">
-            <a:off x="3627297" y="1457714"/>
-            <a:ext cx="875334" cy="4037404"/>
+            <a:off x="3621451" y="1503716"/>
+            <a:ext cx="835178" cy="3985556"/>
           </a:xfrm>
           <a:prstGeom prst="bentConnector3">
             <a:avLst>
-              <a:gd name="adj1" fmla="val 16710"/>
+              <a:gd name="adj1" fmla="val 14882"/>
             </a:avLst>
           </a:prstGeom>
           <a:ln w="15875">
@@ -3004,7 +3004,7 @@
         </p:nvSpPr>
         <p:spPr>
           <a:xfrm>
-            <a:off x="553796" y="2093378"/>
+            <a:off x="553796" y="1981200"/>
             <a:ext cx="256032" cy="256032"/>
           </a:xfrm>
           <a:prstGeom prst="ellipse">
@@ -3223,7 +3223,7 @@
         </p:blipFill>
         <p:spPr bwMode="auto">
           <a:xfrm>
-            <a:off x="7563142" y="2311282"/>
+            <a:off x="7563142" y="2258234"/>
             <a:ext cx="365760" cy="365760"/>
           </a:xfrm>
           <a:prstGeom prst="rect">
@@ -3548,7 +3548,7 @@
         </p:blipFill>
         <p:spPr bwMode="auto">
           <a:xfrm flipH="1">
-            <a:off x="259657" y="2311282"/>
+            <a:off x="259657" y="2258234"/>
             <a:ext cx="365760" cy="365760"/>
           </a:xfrm>
           <a:prstGeom prst="rect">
@@ -3710,8 +3710,8 @@
         </p:nvSpPr>
         <p:spPr>
           <a:xfrm>
-            <a:off x="9418013" y="97127"/>
-            <a:ext cx="2756913" cy="6694140"/>
+            <a:off x="9375037" y="51471"/>
+            <a:ext cx="2822974" cy="7001917"/>
           </a:xfrm>
           <a:prstGeom prst="rect">
             <a:avLst/>
@@ -3779,7 +3779,7 @@
                 </a:solidFill>
                 <a:latin typeface="Arial"/>
               </a:rPr>
-              <a:t>Amazon Connect Contact Flow </a:t>
+              <a:t>Amazon Connect Contact Flow sets the Agentic Voice, </a:t>
             </a:r>
             <a:r>
               <a:rPr lang="en-US" sz="1000" b="0" dirty="0">
@@ -3806,7 +3806,7 @@
                 </a:solidFill>
                 <a:latin typeface="Arial"/>
               </a:rPr>
-              <a:t> session, and plays the greeting to the caller.</a:t>
+              <a:t> session, pushes the caller’s phone number into the session and plays the greeting to the caller.</a:t>
             </a:r>
             <a:endParaRPr sz="1000" b="0" dirty="0">
               <a:solidFill>
@@ -3855,7 +3855,7 @@
                 </a:solidFill>
                 <a:latin typeface="Arial"/>
               </a:rPr>
-              <a:t>Nova Sonic generative engine</a:t>
+              <a:t>Amazon Connect Agentic Voice</a:t>
             </a:r>
             <a:r>
               <a:rPr lang="en-US" sz="1000" b="0" dirty="0">
@@ -3953,7 +3953,7 @@
                 </a:solidFill>
                 <a:latin typeface="Arial"/>
               </a:rPr>
-              <a:t>Amazon Connect AI Agents </a:t>
+              <a:t>Amazon Connect AI Agents</a:t>
             </a:r>
             <a:r>
               <a:rPr lang="en-US" sz="1000" b="0" dirty="0">
@@ -3962,7 +3962,7 @@
                 </a:solidFill>
                 <a:latin typeface="Arial"/>
               </a:rPr>
-              <a:t>AI Agent, powered by </a:t>
+              <a:t>, powered by </a:t>
             </a:r>
             <a:r>
               <a:rPr lang="en-US" sz="1000" b="1" dirty="0">
@@ -3980,7 +3980,25 @@
                 </a:solidFill>
                 <a:latin typeface="Arial"/>
               </a:rPr>
-              <a:t>, drives the conversation – resolving the caller’s location, fetching the menu, managing the cart, and placing the order.</a:t>
+              <a:t>, </a:t>
+            </a:r>
+            <a:r>
+              <a:rPr lang="en-US" sz="1000" dirty="0">
+                <a:solidFill>
+                  <a:srgbClr val="16191F"/>
+                </a:solidFill>
+                <a:latin typeface="Arial"/>
+              </a:rPr>
+              <a:t>with AI Guardrail for content safety, </a:t>
+            </a:r>
+            <a:r>
+              <a:rPr lang="en-US" sz="1000" b="0" dirty="0">
+                <a:solidFill>
+                  <a:srgbClr val="16191F"/>
+                </a:solidFill>
+                <a:latin typeface="Arial"/>
+              </a:rPr>
+              <a:t>drives the conversation - resolving the caller’s location, fetching the menu, managing the cart, and placing the order.</a:t>
             </a:r>
             <a:endParaRPr sz="1000" b="0" dirty="0">
               <a:solidFill>
@@ -4397,7 +4415,7 @@
         </p:nvSpPr>
         <p:spPr>
           <a:xfrm>
-            <a:off x="9077016" y="2260432"/>
+            <a:off x="9077016" y="2334768"/>
             <a:ext cx="256032" cy="256032"/>
           </a:xfrm>
           <a:prstGeom prst="ellipse">
@@ -4449,7 +4467,7 @@
         </p:nvSpPr>
         <p:spPr>
           <a:xfrm>
-            <a:off x="9076521" y="3060848"/>
+            <a:off x="9076521" y="2895600"/>
             <a:ext cx="256032" cy="256032"/>
           </a:xfrm>
           <a:prstGeom prst="ellipse">
@@ -4501,7 +4519,7 @@
         </p:nvSpPr>
         <p:spPr>
           <a:xfrm>
-            <a:off x="9073373" y="4552359"/>
+            <a:off x="9073373" y="4495800"/>
             <a:ext cx="256032" cy="256032"/>
           </a:xfrm>
           <a:prstGeom prst="ellipse">
@@ -4559,7 +4577,7 @@
         </p:nvSpPr>
         <p:spPr>
           <a:xfrm>
-            <a:off x="9073373" y="4999893"/>
+            <a:off x="9073373" y="5077968"/>
             <a:ext cx="256032" cy="256032"/>
           </a:xfrm>
           <a:prstGeom prst="ellipse">
@@ -4617,7 +4635,7 @@
         </p:nvSpPr>
         <p:spPr>
           <a:xfrm>
-            <a:off x="9080994" y="5730884"/>
+            <a:off x="9080994" y="5839968"/>
             <a:ext cx="256032" cy="256032"/>
           </a:xfrm>
           <a:prstGeom prst="ellipse">
@@ -4669,7 +4687,7 @@
         </p:nvSpPr>
         <p:spPr>
           <a:xfrm>
-            <a:off x="9069271" y="6162836"/>
+            <a:off x="9069271" y="6297168"/>
             <a:ext cx="256032" cy="256032"/>
           </a:xfrm>
           <a:prstGeom prst="ellipse">
@@ -4721,7 +4739,7 @@
         </p:nvSpPr>
         <p:spPr>
           <a:xfrm>
-            <a:off x="1516518" y="5168685"/>
+            <a:off x="1512375" y="5087678"/>
             <a:ext cx="256032" cy="256032"/>
           </a:xfrm>
           <a:prstGeom prst="ellipse">
@@ -4840,7 +4858,7 @@
         </p:blipFill>
         <p:spPr>
           <a:xfrm>
-            <a:off x="1463999" y="5461367"/>
+            <a:off x="1458925" y="5385100"/>
             <a:ext cx="365760" cy="365760"/>
           </a:xfrm>
           <a:prstGeom prst="rect">
@@ -4856,7 +4874,7 @@
         </p:nvSpPr>
         <p:spPr>
           <a:xfrm>
-            <a:off x="1179429" y="5850755"/>
+            <a:off x="1138885" y="5787969"/>
             <a:ext cx="1005840" cy="274320"/>
           </a:xfrm>
           <a:prstGeom prst="rect">
@@ -4899,7 +4917,7 @@
         </p:nvSpPr>
         <p:spPr bwMode="auto">
           <a:xfrm>
-            <a:off x="1474756" y="2678668"/>
+            <a:off x="1479026" y="2596462"/>
             <a:ext cx="1147172" cy="369332"/>
           </a:xfrm>
           <a:prstGeom prst="rect">
@@ -5067,7 +5085,7 @@
         </p:nvCxnSpPr>
         <p:spPr>
           <a:xfrm flipV="1">
-            <a:off x="2229142" y="2480532"/>
+            <a:off x="2229142" y="2427484"/>
             <a:ext cx="1686789" cy="8457"/>
           </a:xfrm>
           <a:prstGeom prst="straightConnector1">
@@ -5110,7 +5128,7 @@
         </p:nvSpPr>
         <p:spPr>
           <a:xfrm>
-            <a:off x="1711229" y="2020091"/>
+            <a:off x="1711229" y="1967043"/>
             <a:ext cx="256032" cy="256032"/>
           </a:xfrm>
           <a:prstGeom prst="ellipse">
@@ -5174,7 +5192,7 @@
         </p:nvSpPr>
         <p:spPr>
           <a:xfrm>
-            <a:off x="6174272" y="2193115"/>
+            <a:off x="6174272" y="2140067"/>
             <a:ext cx="256032" cy="256032"/>
           </a:xfrm>
           <a:prstGeom prst="ellipse">
@@ -5238,7 +5256,7 @@
         </p:nvSpPr>
         <p:spPr>
           <a:xfrm>
-            <a:off x="4412743" y="2189965"/>
+            <a:off x="4412743" y="2136917"/>
             <a:ext cx="256032" cy="256032"/>
           </a:xfrm>
           <a:prstGeom prst="ellipse">
@@ -5302,7 +5320,7 @@
         </p:nvSpPr>
         <p:spPr>
           <a:xfrm>
-            <a:off x="9073373" y="3833853"/>
+            <a:off x="9073373" y="3934968"/>
             <a:ext cx="256032" cy="256032"/>
           </a:xfrm>
           <a:prstGeom prst="ellipse">
@@ -5373,7 +5391,7 @@
         </p:blipFill>
         <p:spPr bwMode="auto">
           <a:xfrm>
-            <a:off x="1863382" y="2306109"/>
+            <a:off x="1863382" y="2253061"/>
             <a:ext cx="365760" cy="365760"/>
           </a:xfrm>
           <a:prstGeom prst="rect">
@@ -5431,7 +5449,7 @@
         </p:blipFill>
         <p:spPr bwMode="auto">
           <a:xfrm>
-            <a:off x="3915931" y="2296042"/>
+            <a:off x="3915931" y="2242994"/>
             <a:ext cx="368979" cy="368979"/>
           </a:xfrm>
           <a:prstGeom prst="rect">
@@ -5478,7 +5496,7 @@
         </p:nvSpPr>
         <p:spPr bwMode="auto">
           <a:xfrm>
-            <a:off x="3145890" y="2669784"/>
+            <a:off x="3145216" y="2593743"/>
             <a:ext cx="1849160" cy="369332"/>
           </a:xfrm>
           <a:prstGeom prst="rect">
@@ -5633,7 +5651,7 @@
                 <a:ea typeface="Amazon Ember" panose="020B0603020204020204" pitchFamily="34" charset="0"/>
                 <a:cs typeface="Arial" panose="020B0604020202020204" pitchFamily="34" charset="0"/>
               </a:rPr>
-              <a:t>Nova Sonic Generative Engine</a:t>
+              <a:t>Amazon Connect Agentic Voice</a:t>
             </a:r>
           </a:p>
         </p:txBody>
@@ -5665,7 +5683,7 @@
         </p:blipFill>
         <p:spPr>
           <a:xfrm>
-            <a:off x="5791200" y="2306109"/>
+            <a:off x="5791200" y="2253061"/>
             <a:ext cx="365760" cy="365760"/>
           </a:xfrm>
           <a:prstGeom prst="rect">
@@ -5691,7 +5709,7 @@
         </p:nvCxnSpPr>
         <p:spPr>
           <a:xfrm>
-            <a:off x="4284910" y="2480532"/>
+            <a:off x="4284910" y="2427484"/>
             <a:ext cx="1506290" cy="8457"/>
           </a:xfrm>
           <a:prstGeom prst="straightConnector1">
@@ -5736,7 +5754,7 @@
         </p:nvSpPr>
         <p:spPr bwMode="auto">
           <a:xfrm>
-            <a:off x="6809827" y="2678668"/>
+            <a:off x="6816837" y="2597170"/>
             <a:ext cx="1849160" cy="369332"/>
           </a:xfrm>
           <a:prstGeom prst="rect">
@@ -5913,8 +5931,8 @@
         </p:nvSpPr>
         <p:spPr bwMode="auto">
           <a:xfrm>
-            <a:off x="5233131" y="2669417"/>
-            <a:ext cx="1701069" cy="369332"/>
+            <a:off x="5097314" y="2571074"/>
+            <a:ext cx="1869007" cy="507831"/>
           </a:xfrm>
           <a:prstGeom prst="rect">
             <a:avLst/>
@@ -6064,7 +6082,7 @@
                 <a:ea typeface="Amazon Ember" panose="020B0603020204020204" pitchFamily="34" charset="0"/>
                 <a:cs typeface="Arial" panose="020B0604020202020204" pitchFamily="34" charset="0"/>
               </a:rPr>
-              <a:t>Orchestration AI Agent </a:t>
+              <a:t>Orchestration AI Agent + AI Guardrails</a:t>
             </a:r>
           </a:p>
         </p:txBody>
@@ -6087,7 +6105,7 @@
         </p:nvCxnSpPr>
         <p:spPr>
           <a:xfrm>
-            <a:off x="6156960" y="2488989"/>
+            <a:off x="6156960" y="2435941"/>
             <a:ext cx="1406182" cy="5173"/>
           </a:xfrm>
           <a:prstGeom prst="straightConnector1">
@@ -6134,7 +6152,7 @@
         </p:nvCxnSpPr>
         <p:spPr>
           <a:xfrm rot="5400000" flipH="1" flipV="1">
-            <a:off x="4010171" y="342200"/>
+            <a:off x="4010171" y="289152"/>
             <a:ext cx="12700" cy="3927818"/>
           </a:xfrm>
           <a:prstGeom prst="bentConnector3">
@@ -6178,7 +6196,7 @@
         </p:nvSpPr>
         <p:spPr>
           <a:xfrm>
-            <a:off x="2633704" y="2189965"/>
+            <a:off x="2633704" y="2136917"/>
             <a:ext cx="256032" cy="256032"/>
           </a:xfrm>
           <a:prstGeom prst="ellipse">

</xml_diff>